<commit_message>
Harden IRC lifecycle, modularize queries and package runtime code
</commit_message>
<xml_diff>
--- a/IRC_Midterm_Visual_Refined_EN.pptx
+++ b/IRC_Midterm_Visual_Refined_EN.pptx
@@ -334,7 +334,7 @@
               <a:rPr lang="zh-CN" altLang="zh-CN" sz="1200" kern="1200" dirty="0">
                 <a:effectLst/>
               </a:rPr>
-              <a:t>Good morning, and thank you for having us. For this midterm review I'll explain how our implementation meets the coursework requirements for a lightweight IPv6 IRC server and command Bot, both built with Python sockets. I'll cover the protocol foundation, the Bot features, the server behavior for multiple clients, and error handling.</a:t>
+              <a:t>Good morning, and thank you for having us. For this midterm review I'll explain how our implementation meets the project requirements for a lightweight IPv6 IRC server and command Bot, both built with Python sockets. I'll cover the protocol foundation, the Bot features, the server behavior for multiple clients, and error handling.</a:t>
             </a:r>
           </a:p>
         </p:txBody>
@@ -431,7 +431,7 @@
               <a:rPr lang="zh-CN" altLang="zh-CN" sz="1200" kern="1200" dirty="0">
                 <a:effectLst/>
               </a:rPr>
-              <a:t>Our group split the implementation into three modules, and every member owns both the code and its documentation. Kun Qian built the common protocol layer with IRCMessage and IRCStreamDecoder. Yibo Xu and She Jingsong handled the server, including client sessions, shared state, and routing. Tianxing Wei and Li Yuzong built the Bot, including the connection client, membership tracking, and command processor. The three modules work together as one IRC system, organized around the coursework requirements.</a:t>
+              <a:t>Our group split the implementation into three modules, and every member owns both the code and its documentation. Kun Qian built the common protocol layer with IRCMessage and IRCStreamDecoder. Yibo Xu and She Jingsong handled the server, including client sessions, shared state, and routing. Tianxing Wei and Li Yuzong built the Bot, including the connection client, membership tracking, and command processor. The three modules work together as one IRC system, organized around the project requirements.</a:t>
             </a:r>
             <a:r>
               <a:rPr lang="en-US" altLang="zh-CN" sz="1200" kern="1200" dirty="0">
@@ -796,7 +796,7 @@
               <a:rPr lang="zh-CN" altLang="zh-CN" sz="1200" kern="1200" dirty="0">
                 <a:effectLst/>
               </a:rPr>
-              <a:t>The final implementation area is error handling and reliability. The server returns numeric errors for missing parameters, invalid channels, duplicate nicknames and unknown targets. It checks the encoded UTF-8 length of relayed PRIVMSG messages and returns 417 when the IRC limit would be exceeded. Malformed input stays isolated to one session, while disconnect cleanup, nickname reuse and PING timeout handling keep shared state correct. These behaviors cover the main coursework requirements for reliable server operation.</a:t>
+              <a:t>The final implementation area is error handling and reliability. The server returns numeric errors for missing parameters, invalid channels, duplicate nicknames and unknown targets. It checks the encoded UTF-8 length of relayed PRIVMSG messages and returns 417 when the IRC limit would be exceeded. Malformed input stays isolated to one session, while disconnect cleanup, nickname reuse and PING timeout handling keep shared state correct. These behaviors cover the main project requirements for reliable server operation.</a:t>
             </a:r>
           </a:p>
         </p:txBody>
@@ -1446,7 +1446,7 @@
                 <a:ea typeface="Arial"/>
                 <a:cs typeface="Arial"/>
               </a:rPr>
-              <a:t>Coursework requirements</a:t>
+              <a:t>project requirements</a:t>
             </a:r>
           </a:p>
           <a:p>
@@ -6651,7 +6651,7 @@
                 <a:ea typeface="Arial"/>
                 <a:cs typeface="Arial"/>
               </a:rPr>
-              <a:t>Coursework error-handling requirements implemented.</a:t>
+              <a:t>project error-handling requirements implemented.</a:t>
             </a:r>
           </a:p>
         </p:txBody>

</xml_diff>